<commit_message>
new graphs and simulation
</commit_message>
<xml_diff>
--- a/presentation/FCFS Presentation.pptx
+++ b/presentation/FCFS Presentation.pptx
@@ -5,15 +5,15 @@
     <p:sldMasterId id="2147483826" r:id="rId1"/>
   </p:sldMasterIdLst>
   <p:notesMasterIdLst>
-    <p:notesMasterId r:id="rId15"/>
+    <p:notesMasterId r:id="rId20"/>
   </p:notesMasterIdLst>
   <p:sldIdLst>
     <p:sldId id="256" r:id="rId2"/>
     <p:sldId id="265" r:id="rId3"/>
     <p:sldId id="269" r:id="rId4"/>
     <p:sldId id="257" r:id="rId5"/>
-    <p:sldId id="270" r:id="rId6"/>
-    <p:sldId id="271" r:id="rId7"/>
+    <p:sldId id="271" r:id="rId6"/>
+    <p:sldId id="270" r:id="rId7"/>
     <p:sldId id="268" r:id="rId8"/>
     <p:sldId id="260" r:id="rId9"/>
     <p:sldId id="261" r:id="rId10"/>
@@ -21,6 +21,11 @@
     <p:sldId id="266" r:id="rId12"/>
     <p:sldId id="267" r:id="rId13"/>
     <p:sldId id="272" r:id="rId14"/>
+    <p:sldId id="273" r:id="rId15"/>
+    <p:sldId id="274" r:id="rId16"/>
+    <p:sldId id="275" r:id="rId17"/>
+    <p:sldId id="277" r:id="rId18"/>
+    <p:sldId id="276" r:id="rId19"/>
   </p:sldIdLst>
   <p:sldSz cx="12192000" cy="6858000"/>
   <p:notesSz cx="6858000" cy="9144000"/>
@@ -209,7 +214,7 @@
           <a:p>
             <a:fld id="{A3F00E0A-26B8-438F-8C49-C4126C0B2F07}" type="datetimeFigureOut">
               <a:rPr lang="en-CA" smtClean="0"/>
-              <a:t>2026-09-07</a:t>
+              <a:t>2026-09-13</a:t>
             </a:fld>
             <a:endParaRPr lang="en-CA"/>
           </a:p>
@@ -561,6 +566,93 @@
 </p:notes>
 </file>
 
+<file path=ppt/notesSlides/notesSlide10.xml><?xml version="1.0" encoding="utf-8"?>
+<p:notes xmlns:a="http://schemas.openxmlformats.org/drawingml/2006/main" xmlns:r="http://schemas.openxmlformats.org/officeDocument/2006/relationships" xmlns:p="http://schemas.openxmlformats.org/presentationml/2006/main">
+  <p:cSld>
+    <p:spTree>
+      <p:nvGrpSpPr>
+        <p:cNvPr id="1" name=""/>
+        <p:cNvGrpSpPr/>
+        <p:nvPr/>
+      </p:nvGrpSpPr>
+      <p:grpSpPr>
+        <a:xfrm>
+          <a:off x="0" y="0"/>
+          <a:ext cx="0" cy="0"/>
+          <a:chOff x="0" y="0"/>
+          <a:chExt cx="0" cy="0"/>
+        </a:xfrm>
+      </p:grpSpPr>
+      <p:sp>
+        <p:nvSpPr>
+          <p:cNvPr id="2" name="Slide Image Placeholder 1"/>
+          <p:cNvSpPr>
+            <a:spLocks noGrp="1" noRot="1" noChangeAspect="1"/>
+          </p:cNvSpPr>
+          <p:nvPr>
+            <p:ph type="sldImg"/>
+          </p:nvPr>
+        </p:nvSpPr>
+        <p:spPr/>
+      </p:sp>
+      <p:sp>
+        <p:nvSpPr>
+          <p:cNvPr id="3" name="Notes Placeholder 2"/>
+          <p:cNvSpPr>
+            <a:spLocks noGrp="1"/>
+          </p:cNvSpPr>
+          <p:nvPr>
+            <p:ph type="body" idx="1"/>
+          </p:nvPr>
+        </p:nvSpPr>
+        <p:spPr/>
+        <p:txBody>
+          <a:bodyPr/>
+          <a:lstStyle/>
+          <a:p>
+            <a:r>
+              <a:rPr lang="en-CA" dirty="0"/>
+              <a:t>Take out specific values</a:t>
+            </a:r>
+          </a:p>
+        </p:txBody>
+      </p:sp>
+      <p:sp>
+        <p:nvSpPr>
+          <p:cNvPr id="4" name="Slide Number Placeholder 3"/>
+          <p:cNvSpPr>
+            <a:spLocks noGrp="1"/>
+          </p:cNvSpPr>
+          <p:nvPr>
+            <p:ph type="sldNum" sz="quarter" idx="5"/>
+          </p:nvPr>
+        </p:nvSpPr>
+        <p:spPr/>
+        <p:txBody>
+          <a:bodyPr/>
+          <a:lstStyle/>
+          <a:p>
+            <a:fld id="{6C0CC533-38F2-4480-88E0-3DE04AB45AF2}" type="slidenum">
+              <a:rPr lang="en-CA" smtClean="0"/>
+              <a:t>16</a:t>
+            </a:fld>
+            <a:endParaRPr lang="en-CA"/>
+          </a:p>
+        </p:txBody>
+      </p:sp>
+    </p:spTree>
+    <p:extLst>
+      <p:ext uri="{BB962C8B-B14F-4D97-AF65-F5344CB8AC3E}">
+        <p14:creationId xmlns:p14="http://schemas.microsoft.com/office/powerpoint/2010/main" val="1479815181"/>
+      </p:ext>
+    </p:extLst>
+  </p:cSld>
+  <p:clrMapOvr>
+    <a:masterClrMapping/>
+  </p:clrMapOvr>
+</p:notes>
+</file>
+
 <file path=ppt/notesSlides/notesSlide2.xml><?xml version="1.0" encoding="utf-8"?>
 <p:notes xmlns:a="http://schemas.openxmlformats.org/drawingml/2006/main" xmlns:r="http://schemas.openxmlformats.org/officeDocument/2006/relationships" xmlns:p="http://schemas.openxmlformats.org/presentationml/2006/main">
   <p:cSld>
@@ -710,7 +802,7 @@
           <a:p>
             <a:fld id="{6C0CC533-38F2-4480-88E0-3DE04AB45AF2}" type="slidenum">
               <a:rPr lang="en-CA" smtClean="0"/>
-              <a:t>5</a:t>
+              <a:t>6</a:t>
             </a:fld>
             <a:endParaRPr lang="en-CA"/>
           </a:p>
@@ -858,9 +950,10 @@
           <a:lstStyle/>
           <a:p>
             <a:r>
-              <a:rPr lang="en-CA" dirty="0"/>
-              <a:t>Class 1 is the delay sensitive class, difference in served rate between class 1 and class 2 – on y axis</a:t>
-            </a:r>
+              <a:rPr lang="en-CA"/>
+              <a:t>6 figures, served rate on y, class 1 and class 2 served rates on the figures</a:t>
+            </a:r>
+            <a:endParaRPr lang="en-CA" dirty="0"/>
           </a:p>
         </p:txBody>
       </p:sp>
@@ -1059,6 +1152,180 @@
     <p:extLst>
       <p:ext uri="{BB962C8B-B14F-4D97-AF65-F5344CB8AC3E}">
         <p14:creationId xmlns:p14="http://schemas.microsoft.com/office/powerpoint/2010/main" val="2102681076"/>
+      </p:ext>
+    </p:extLst>
+  </p:cSld>
+  <p:clrMapOvr>
+    <a:masterClrMapping/>
+  </p:clrMapOvr>
+</p:notes>
+</file>
+
+<file path=ppt/notesSlides/notesSlide8.xml><?xml version="1.0" encoding="utf-8"?>
+<p:notes xmlns:a="http://schemas.openxmlformats.org/drawingml/2006/main" xmlns:r="http://schemas.openxmlformats.org/officeDocument/2006/relationships" xmlns:p="http://schemas.openxmlformats.org/presentationml/2006/main">
+  <p:cSld>
+    <p:spTree>
+      <p:nvGrpSpPr>
+        <p:cNvPr id="1" name=""/>
+        <p:cNvGrpSpPr/>
+        <p:nvPr/>
+      </p:nvGrpSpPr>
+      <p:grpSpPr>
+        <a:xfrm>
+          <a:off x="0" y="0"/>
+          <a:ext cx="0" cy="0"/>
+          <a:chOff x="0" y="0"/>
+          <a:chExt cx="0" cy="0"/>
+        </a:xfrm>
+      </p:grpSpPr>
+      <p:sp>
+        <p:nvSpPr>
+          <p:cNvPr id="2" name="Slide Image Placeholder 1"/>
+          <p:cNvSpPr>
+            <a:spLocks noGrp="1" noRot="1" noChangeAspect="1"/>
+          </p:cNvSpPr>
+          <p:nvPr>
+            <p:ph type="sldImg"/>
+          </p:nvPr>
+        </p:nvSpPr>
+        <p:spPr/>
+      </p:sp>
+      <p:sp>
+        <p:nvSpPr>
+          <p:cNvPr id="3" name="Notes Placeholder 2"/>
+          <p:cNvSpPr>
+            <a:spLocks noGrp="1"/>
+          </p:cNvSpPr>
+          <p:nvPr>
+            <p:ph type="body" idx="1"/>
+          </p:nvPr>
+        </p:nvSpPr>
+        <p:spPr/>
+        <p:txBody>
+          <a:bodyPr/>
+          <a:lstStyle/>
+          <a:p>
+            <a:r>
+              <a:rPr lang="en-CA" dirty="0"/>
+              <a:t>Switch 1 and 2</a:t>
+            </a:r>
+          </a:p>
+        </p:txBody>
+      </p:sp>
+      <p:sp>
+        <p:nvSpPr>
+          <p:cNvPr id="4" name="Slide Number Placeholder 3"/>
+          <p:cNvSpPr>
+            <a:spLocks noGrp="1"/>
+          </p:cNvSpPr>
+          <p:nvPr>
+            <p:ph type="sldNum" sz="quarter" idx="5"/>
+          </p:nvPr>
+        </p:nvSpPr>
+        <p:spPr/>
+        <p:txBody>
+          <a:bodyPr/>
+          <a:lstStyle/>
+          <a:p>
+            <a:fld id="{6C0CC533-38F2-4480-88E0-3DE04AB45AF2}" type="slidenum">
+              <a:rPr lang="en-CA" smtClean="0"/>
+              <a:t>13</a:t>
+            </a:fld>
+            <a:endParaRPr lang="en-CA"/>
+          </a:p>
+        </p:txBody>
+      </p:sp>
+    </p:spTree>
+    <p:extLst>
+      <p:ext uri="{BB962C8B-B14F-4D97-AF65-F5344CB8AC3E}">
+        <p14:creationId xmlns:p14="http://schemas.microsoft.com/office/powerpoint/2010/main" val="92277621"/>
+      </p:ext>
+    </p:extLst>
+  </p:cSld>
+  <p:clrMapOvr>
+    <a:masterClrMapping/>
+  </p:clrMapOvr>
+</p:notes>
+</file>
+
+<file path=ppt/notesSlides/notesSlide9.xml><?xml version="1.0" encoding="utf-8"?>
+<p:notes xmlns:a="http://schemas.openxmlformats.org/drawingml/2006/main" xmlns:r="http://schemas.openxmlformats.org/officeDocument/2006/relationships" xmlns:p="http://schemas.openxmlformats.org/presentationml/2006/main">
+  <p:cSld>
+    <p:spTree>
+      <p:nvGrpSpPr>
+        <p:cNvPr id="1" name=""/>
+        <p:cNvGrpSpPr/>
+        <p:nvPr/>
+      </p:nvGrpSpPr>
+      <p:grpSpPr>
+        <a:xfrm>
+          <a:off x="0" y="0"/>
+          <a:ext cx="0" cy="0"/>
+          <a:chOff x="0" y="0"/>
+          <a:chExt cx="0" cy="0"/>
+        </a:xfrm>
+      </p:grpSpPr>
+      <p:sp>
+        <p:nvSpPr>
+          <p:cNvPr id="2" name="Slide Image Placeholder 1"/>
+          <p:cNvSpPr>
+            <a:spLocks noGrp="1" noRot="1" noChangeAspect="1"/>
+          </p:cNvSpPr>
+          <p:nvPr>
+            <p:ph type="sldImg"/>
+          </p:nvPr>
+        </p:nvSpPr>
+        <p:spPr/>
+      </p:sp>
+      <p:sp>
+        <p:nvSpPr>
+          <p:cNvPr id="3" name="Notes Placeholder 2"/>
+          <p:cNvSpPr>
+            <a:spLocks noGrp="1"/>
+          </p:cNvSpPr>
+          <p:nvPr>
+            <p:ph type="body" idx="1"/>
+          </p:nvPr>
+        </p:nvSpPr>
+        <p:spPr/>
+        <p:txBody>
+          <a:bodyPr/>
+          <a:lstStyle/>
+          <a:p>
+            <a:r>
+              <a:rPr lang="en-CA" dirty="0"/>
+              <a:t>Served rate optimization?, change to magnitude for x axis</a:t>
+            </a:r>
+          </a:p>
+        </p:txBody>
+      </p:sp>
+      <p:sp>
+        <p:nvSpPr>
+          <p:cNvPr id="4" name="Slide Number Placeholder 3"/>
+          <p:cNvSpPr>
+            <a:spLocks noGrp="1"/>
+          </p:cNvSpPr>
+          <p:nvPr>
+            <p:ph type="sldNum" sz="quarter" idx="5"/>
+          </p:nvPr>
+        </p:nvSpPr>
+        <p:spPr/>
+        <p:txBody>
+          <a:bodyPr/>
+          <a:lstStyle/>
+          <a:p>
+            <a:fld id="{6C0CC533-38F2-4480-88E0-3DE04AB45AF2}" type="slidenum">
+              <a:rPr lang="en-CA" smtClean="0"/>
+              <a:t>15</a:t>
+            </a:fld>
+            <a:endParaRPr lang="en-CA"/>
+          </a:p>
+        </p:txBody>
+      </p:sp>
+    </p:spTree>
+    <p:extLst>
+      <p:ext uri="{BB962C8B-B14F-4D97-AF65-F5344CB8AC3E}">
+        <p14:creationId xmlns:p14="http://schemas.microsoft.com/office/powerpoint/2010/main" val="986733767"/>
       </p:ext>
     </p:extLst>
   </p:cSld>
@@ -1199,7 +1466,7 @@
           <a:p>
             <a:fld id="{7559F276-CA16-4B7F-AC4C-2EDD18BC89A1}" type="datetimeFigureOut">
               <a:rPr lang="en-CA" smtClean="0"/>
-              <a:t>2026-09-07</a:t>
+              <a:t>2026-09-13</a:t>
             </a:fld>
             <a:endParaRPr lang="en-CA"/>
           </a:p>
@@ -1369,7 +1636,7 @@
           <a:p>
             <a:fld id="{7559F276-CA16-4B7F-AC4C-2EDD18BC89A1}" type="datetimeFigureOut">
               <a:rPr lang="en-CA" smtClean="0"/>
-              <a:t>2026-09-07</a:t>
+              <a:t>2026-09-13</a:t>
             </a:fld>
             <a:endParaRPr lang="en-CA"/>
           </a:p>
@@ -1549,7 +1816,7 @@
           <a:p>
             <a:fld id="{7559F276-CA16-4B7F-AC4C-2EDD18BC89A1}" type="datetimeFigureOut">
               <a:rPr lang="en-CA" smtClean="0"/>
-              <a:t>2026-09-07</a:t>
+              <a:t>2026-09-13</a:t>
             </a:fld>
             <a:endParaRPr lang="en-CA"/>
           </a:p>
@@ -1719,7 +1986,7 @@
           <a:p>
             <a:fld id="{7559F276-CA16-4B7F-AC4C-2EDD18BC89A1}" type="datetimeFigureOut">
               <a:rPr lang="en-CA" smtClean="0"/>
-              <a:t>2026-09-07</a:t>
+              <a:t>2026-09-13</a:t>
             </a:fld>
             <a:endParaRPr lang="en-CA"/>
           </a:p>
@@ -1965,7 +2232,7 @@
           <a:p>
             <a:fld id="{7559F276-CA16-4B7F-AC4C-2EDD18BC89A1}" type="datetimeFigureOut">
               <a:rPr lang="en-CA" smtClean="0"/>
-              <a:t>2026-09-07</a:t>
+              <a:t>2026-09-13</a:t>
             </a:fld>
             <a:endParaRPr lang="en-CA"/>
           </a:p>
@@ -2197,7 +2464,7 @@
           <a:p>
             <a:fld id="{7559F276-CA16-4B7F-AC4C-2EDD18BC89A1}" type="datetimeFigureOut">
               <a:rPr lang="en-CA" smtClean="0"/>
-              <a:t>2026-09-07</a:t>
+              <a:t>2026-09-13</a:t>
             </a:fld>
             <a:endParaRPr lang="en-CA"/>
           </a:p>
@@ -2564,7 +2831,7 @@
           <a:p>
             <a:fld id="{7559F276-CA16-4B7F-AC4C-2EDD18BC89A1}" type="datetimeFigureOut">
               <a:rPr lang="en-CA" smtClean="0"/>
-              <a:t>2026-09-07</a:t>
+              <a:t>2026-09-13</a:t>
             </a:fld>
             <a:endParaRPr lang="en-CA"/>
           </a:p>
@@ -2682,7 +2949,7 @@
           <a:p>
             <a:fld id="{7559F276-CA16-4B7F-AC4C-2EDD18BC89A1}" type="datetimeFigureOut">
               <a:rPr lang="en-CA" smtClean="0"/>
-              <a:t>2026-09-07</a:t>
+              <a:t>2026-09-13</a:t>
             </a:fld>
             <a:endParaRPr lang="en-CA"/>
           </a:p>
@@ -2777,7 +3044,7 @@
           <a:p>
             <a:fld id="{7559F276-CA16-4B7F-AC4C-2EDD18BC89A1}" type="datetimeFigureOut">
               <a:rPr lang="en-CA" smtClean="0"/>
-              <a:t>2026-09-07</a:t>
+              <a:t>2026-09-13</a:t>
             </a:fld>
             <a:endParaRPr lang="en-CA"/>
           </a:p>
@@ -3054,7 +3321,7 @@
           <a:p>
             <a:fld id="{7559F276-CA16-4B7F-AC4C-2EDD18BC89A1}" type="datetimeFigureOut">
               <a:rPr lang="en-CA" smtClean="0"/>
-              <a:t>2026-09-07</a:t>
+              <a:t>2026-09-13</a:t>
             </a:fld>
             <a:endParaRPr lang="en-CA"/>
           </a:p>
@@ -3311,7 +3578,7 @@
           <a:p>
             <a:fld id="{7559F276-CA16-4B7F-AC4C-2EDD18BC89A1}" type="datetimeFigureOut">
               <a:rPr lang="en-CA" smtClean="0"/>
-              <a:t>2026-09-07</a:t>
+              <a:t>2026-09-13</a:t>
             </a:fld>
             <a:endParaRPr lang="en-CA"/>
           </a:p>
@@ -3524,7 +3791,7 @@
           <a:p>
             <a:fld id="{7559F276-CA16-4B7F-AC4C-2EDD18BC89A1}" type="datetimeFigureOut">
               <a:rPr lang="en-CA" smtClean="0"/>
-              <a:t>2026-09-07</a:t>
+              <a:t>2026-09-13</a:t>
             </a:fld>
             <a:endParaRPr lang="en-CA"/>
           </a:p>
@@ -4095,34 +4362,6 @@
           </a:p>
         </p:txBody>
       </p:sp>
-      <p:pic>
-        <p:nvPicPr>
-          <p:cNvPr id="4" name="Content Placeholder 8">
-            <a:extLst>
-              <a:ext uri="{FF2B5EF4-FFF2-40B4-BE49-F238E27FC236}">
-                <a16:creationId xmlns:a16="http://schemas.microsoft.com/office/drawing/2014/main" id="{A6C18586-3ECC-41E4-925E-079E425422DA}"/>
-              </a:ext>
-            </a:extLst>
-          </p:cNvPr>
-          <p:cNvPicPr>
-            <a:picLocks noGrp="1" noChangeAspect="1"/>
-          </p:cNvPicPr>
-          <p:nvPr>
-            <p:ph idx="1"/>
-          </p:nvPr>
-        </p:nvPicPr>
-        <p:blipFill rotWithShape="1">
-          <a:blip r:embed="rId3"/>
-          <a:srcRect l="894"/>
-          <a:stretch/>
-        </p:blipFill>
-        <p:spPr>
-          <a:xfrm>
-            <a:off x="439400" y="1600200"/>
-            <a:ext cx="5562009" cy="3532504"/>
-          </a:xfrm>
-        </p:spPr>
-      </p:pic>
       <p:sp>
         <p:nvSpPr>
           <p:cNvPr id="5" name="Content Placeholder 11">
@@ -4330,10 +4569,45 @@
       </p:sp>
       <p:pic>
         <p:nvPicPr>
-          <p:cNvPr id="6" name="Content Placeholder 4">
+          <p:cNvPr id="9" name="Content Placeholder 8">
             <a:extLst>
               <a:ext uri="{FF2B5EF4-FFF2-40B4-BE49-F238E27FC236}">
-                <a16:creationId xmlns:a16="http://schemas.microsoft.com/office/drawing/2014/main" id="{40932703-1B5B-4BE8-BB30-66B2474230B0}"/>
+                <a16:creationId xmlns:a16="http://schemas.microsoft.com/office/drawing/2014/main" id="{7F751082-0A6E-4A93-89BF-226CD1AFA881}"/>
+              </a:ext>
+            </a:extLst>
+          </p:cNvPr>
+          <p:cNvPicPr>
+            <a:picLocks noGrp="1" noChangeAspect="1"/>
+          </p:cNvPicPr>
+          <p:nvPr>
+            <p:ph idx="1"/>
+          </p:nvPr>
+        </p:nvPicPr>
+        <p:blipFill>
+          <a:blip r:embed="rId3">
+            <a:extLst>
+              <a:ext uri="{28A0092B-C50C-407E-A947-70E740481C1C}">
+                <a14:useLocalDpi xmlns:a14="http://schemas.microsoft.com/office/drawing/2010/main" val="0"/>
+              </a:ext>
+            </a:extLst>
+          </a:blip>
+          <a:stretch>
+            <a:fillRect/>
+          </a:stretch>
+        </p:blipFill>
+        <p:spPr>
+          <a:xfrm>
+            <a:off x="354815" y="1611044"/>
+            <a:ext cx="5741185" cy="3618315"/>
+          </a:xfrm>
+        </p:spPr>
+      </p:pic>
+      <p:pic>
+        <p:nvPicPr>
+          <p:cNvPr id="11" name="Picture 10">
+            <a:extLst>
+              <a:ext uri="{FF2B5EF4-FFF2-40B4-BE49-F238E27FC236}">
+                <a16:creationId xmlns:a16="http://schemas.microsoft.com/office/drawing/2014/main" id="{C3AB64E3-04CF-4B8C-98CD-B346944CF797}"/>
               </a:ext>
             </a:extLst>
           </p:cNvPr>
@@ -4343,15 +4617,21 @@
           <p:nvPr/>
         </p:nvPicPr>
         <p:blipFill>
-          <a:blip r:embed="rId4"/>
+          <a:blip r:embed="rId4">
+            <a:extLst>
+              <a:ext uri="{28A0092B-C50C-407E-A947-70E740481C1C}">
+                <a14:useLocalDpi xmlns:a14="http://schemas.microsoft.com/office/drawing/2010/main" val="0"/>
+              </a:ext>
+            </a:extLst>
+          </a:blip>
           <a:stretch>
             <a:fillRect/>
           </a:stretch>
         </p:blipFill>
         <p:spPr>
           <a:xfrm>
-            <a:off x="6133180" y="1600200"/>
-            <a:ext cx="5567408" cy="3532504"/>
+            <a:off x="6187887" y="1602246"/>
+            <a:ext cx="5741186" cy="3618316"/>
           </a:xfrm>
           <a:prstGeom prst="rect">
             <a:avLst/>
@@ -4813,51 +5093,72 @@
         </p:nvSpPr>
         <p:spPr/>
         <p:txBody>
-          <a:bodyPr/>
+          <a:bodyPr>
+            <a:normAutofit/>
+          </a:bodyPr>
           <a:lstStyle/>
           <a:p>
             <a:pPr marL="514350" indent="-514350">
               <a:buAutoNum type="arabicPeriod"/>
             </a:pPr>
             <a:r>
-              <a:rPr lang="en-CA" dirty="0"/>
+              <a:rPr lang="en-CA" sz="3200" dirty="0"/>
               <a:t>Reservation</a:t>
             </a:r>
           </a:p>
           <a:p>
             <a:pPr lvl="1"/>
             <a:r>
-              <a:rPr lang="en-CA" dirty="0"/>
+              <a:rPr lang="en-CA" sz="2800" dirty="0"/>
               <a:t>Allowing one class to have priority for certain appointments.</a:t>
             </a:r>
           </a:p>
           <a:p>
             <a:pPr lvl="1"/>
             <a:r>
-              <a:rPr lang="en-CA" dirty="0"/>
-              <a:t>This policy chooses both reserved slots per day and reservation horizon.</a:t>
-            </a:r>
-          </a:p>
-          <a:p>
-            <a:pPr marL="514350" indent="-514350">
+              <a:rPr lang="en-CA" sz="2800" dirty="0"/>
+              <a:t>This policy chooses both reserved slots per day and overall number of days that slots are reserved.</a:t>
+            </a:r>
+          </a:p>
+          <a:p>
+            <a:pPr marL="342900" indent="-342900">
+              <a:buFont typeface="+mj-lt"/>
               <a:buAutoNum type="arabicPeriod"/>
             </a:pPr>
-            <a:endParaRPr lang="en-CA" dirty="0"/>
-          </a:p>
-          <a:p>
-            <a:pPr marL="0" indent="0">
-              <a:buNone/>
+            <a:endParaRPr lang="en-CA" sz="1600" dirty="0"/>
+          </a:p>
+          <a:p>
+            <a:pPr marL="514350" indent="-514350">
+              <a:buFont typeface="+mj-lt"/>
+              <a:buAutoNum type="arabicPeriod"/>
             </a:pPr>
             <a:r>
-              <a:rPr lang="en-CA" dirty="0"/>
-              <a:t>2. Booking horizon</a:t>
+              <a:rPr lang="en-CA" sz="3200" dirty="0"/>
+              <a:t>Booking horizon   </a:t>
             </a:r>
           </a:p>
           <a:p>
             <a:pPr lvl="1"/>
             <a:r>
-              <a:rPr lang="en-CA" dirty="0"/>
-              <a:t>Adjusting how early an appointment booking is allowed.</a:t>
+              <a:rPr lang="en-CA" sz="2800" dirty="0"/>
+              <a:t>The horizon which bookings are restricted to</a:t>
+            </a:r>
+          </a:p>
+          <a:p>
+            <a:pPr marL="971550" lvl="1" indent="-514350">
+              <a:buFont typeface="+mj-lt"/>
+              <a:buAutoNum type="arabicPeriod"/>
+            </a:pPr>
+            <a:endParaRPr lang="en-CA" sz="2800" dirty="0"/>
+          </a:p>
+          <a:p>
+            <a:pPr marL="514350" indent="-514350">
+              <a:buFont typeface="+mj-lt"/>
+              <a:buAutoNum type="arabicPeriod"/>
+            </a:pPr>
+            <a:r>
+              <a:rPr lang="en-CA" sz="3200" dirty="0"/>
+              <a:t>Combination of reservation and booking horizon</a:t>
             </a:r>
           </a:p>
         </p:txBody>
@@ -4909,6 +5210,467 @@
     <p:extLst>
       <p:ext uri="{BB962C8B-B14F-4D97-AF65-F5344CB8AC3E}">
         <p14:creationId xmlns:p14="http://schemas.microsoft.com/office/powerpoint/2010/main" val="4244925151"/>
+      </p:ext>
+    </p:extLst>
+  </p:cSld>
+  <p:clrMapOvr>
+    <a:masterClrMapping/>
+  </p:clrMapOvr>
+</p:sld>
+</file>
+
+<file path=ppt/slides/slide14.xml><?xml version="1.0" encoding="utf-8"?>
+<p:sld xmlns:a="http://schemas.openxmlformats.org/drawingml/2006/main" xmlns:r="http://schemas.openxmlformats.org/officeDocument/2006/relationships" xmlns:p="http://schemas.openxmlformats.org/presentationml/2006/main">
+  <p:cSld>
+    <p:spTree>
+      <p:nvGrpSpPr>
+        <p:cNvPr id="1" name=""/>
+        <p:cNvGrpSpPr/>
+        <p:nvPr/>
+      </p:nvGrpSpPr>
+      <p:grpSpPr>
+        <a:xfrm>
+          <a:off x="0" y="0"/>
+          <a:ext cx="0" cy="0"/>
+          <a:chOff x="0" y="0"/>
+          <a:chExt cx="0" cy="0"/>
+        </a:xfrm>
+      </p:grpSpPr>
+      <p:sp>
+        <p:nvSpPr>
+          <p:cNvPr id="2" name="Title 1">
+            <a:extLst>
+              <a:ext uri="{FF2B5EF4-FFF2-40B4-BE49-F238E27FC236}">
+                <a16:creationId xmlns:a16="http://schemas.microsoft.com/office/drawing/2014/main" id="{67F5C4C4-80CF-4F67-9AFC-77396B476FB2}"/>
+              </a:ext>
+            </a:extLst>
+          </p:cNvPr>
+          <p:cNvSpPr>
+            <a:spLocks noGrp="1"/>
+          </p:cNvSpPr>
+          <p:nvPr>
+            <p:ph type="title"/>
+          </p:nvPr>
+        </p:nvSpPr>
+        <p:spPr/>
+        <p:txBody>
+          <a:bodyPr/>
+          <a:lstStyle/>
+          <a:p>
+            <a:r>
+              <a:rPr lang="en-CA" dirty="0"/>
+              <a:t>Explaining the 3x3 design</a:t>
+            </a:r>
+          </a:p>
+        </p:txBody>
+      </p:sp>
+      <p:pic>
+        <p:nvPicPr>
+          <p:cNvPr id="5" name="Picture 4">
+            <a:extLst>
+              <a:ext uri="{FF2B5EF4-FFF2-40B4-BE49-F238E27FC236}">
+                <a16:creationId xmlns:a16="http://schemas.microsoft.com/office/drawing/2014/main" id="{A9D7B691-E95A-45B5-AF53-DC56DE6D79C3}"/>
+              </a:ext>
+            </a:extLst>
+          </p:cNvPr>
+          <p:cNvPicPr>
+            <a:picLocks noChangeAspect="1"/>
+          </p:cNvPicPr>
+          <p:nvPr/>
+        </p:nvPicPr>
+        <p:blipFill>
+          <a:blip r:embed="rId2"/>
+          <a:stretch>
+            <a:fillRect/>
+          </a:stretch>
+        </p:blipFill>
+        <p:spPr>
+          <a:xfrm>
+            <a:off x="2601117" y="1690688"/>
+            <a:ext cx="6687262" cy="4267980"/>
+          </a:xfrm>
+          <a:prstGeom prst="rect">
+            <a:avLst/>
+          </a:prstGeom>
+        </p:spPr>
+      </p:pic>
+    </p:spTree>
+    <p:extLst>
+      <p:ext uri="{BB962C8B-B14F-4D97-AF65-F5344CB8AC3E}">
+        <p14:creationId xmlns:p14="http://schemas.microsoft.com/office/powerpoint/2010/main" val="2858968893"/>
+      </p:ext>
+    </p:extLst>
+  </p:cSld>
+  <p:clrMapOvr>
+    <a:masterClrMapping/>
+  </p:clrMapOvr>
+</p:sld>
+</file>
+
+<file path=ppt/slides/slide15.xml><?xml version="1.0" encoding="utf-8"?>
+<p:sld xmlns:a="http://schemas.openxmlformats.org/drawingml/2006/main" xmlns:r="http://schemas.openxmlformats.org/officeDocument/2006/relationships" xmlns:p="http://schemas.openxmlformats.org/presentationml/2006/main">
+  <p:cSld>
+    <p:spTree>
+      <p:nvGrpSpPr>
+        <p:cNvPr id="1" name=""/>
+        <p:cNvGrpSpPr/>
+        <p:nvPr/>
+      </p:nvGrpSpPr>
+      <p:grpSpPr>
+        <a:xfrm>
+          <a:off x="0" y="0"/>
+          <a:ext cx="0" cy="0"/>
+          <a:chOff x="0" y="0"/>
+          <a:chExt cx="0" cy="0"/>
+        </a:xfrm>
+      </p:grpSpPr>
+      <p:sp>
+        <p:nvSpPr>
+          <p:cNvPr id="2" name="Title 1">
+            <a:extLst>
+              <a:ext uri="{FF2B5EF4-FFF2-40B4-BE49-F238E27FC236}">
+                <a16:creationId xmlns:a16="http://schemas.microsoft.com/office/drawing/2014/main" id="{EE19DA39-0AD6-4C52-825B-8541719E5064}"/>
+              </a:ext>
+            </a:extLst>
+          </p:cNvPr>
+          <p:cNvSpPr>
+            <a:spLocks noGrp="1"/>
+          </p:cNvSpPr>
+          <p:nvPr>
+            <p:ph type="title"/>
+          </p:nvPr>
+        </p:nvSpPr>
+        <p:spPr>
+          <a:xfrm>
+            <a:off x="419100" y="500062"/>
+            <a:ext cx="11353800" cy="1325563"/>
+          </a:xfrm>
+        </p:spPr>
+        <p:txBody>
+          <a:bodyPr/>
+          <a:lstStyle/>
+          <a:p>
+            <a:r>
+              <a:rPr lang="en-CA" dirty="0"/>
+              <a:t>No-show magnitude determines the effectiveness of policies on utilization</a:t>
+            </a:r>
+          </a:p>
+        </p:txBody>
+      </p:sp>
+      <p:pic>
+        <p:nvPicPr>
+          <p:cNvPr id="5" name="Picture 4">
+            <a:extLst>
+              <a:ext uri="{FF2B5EF4-FFF2-40B4-BE49-F238E27FC236}">
+                <a16:creationId xmlns:a16="http://schemas.microsoft.com/office/drawing/2014/main" id="{9A667C87-7E73-4639-A614-B8EC62549C5D}"/>
+              </a:ext>
+            </a:extLst>
+          </p:cNvPr>
+          <p:cNvPicPr>
+            <a:picLocks noChangeAspect="1"/>
+          </p:cNvPicPr>
+          <p:nvPr/>
+        </p:nvPicPr>
+        <p:blipFill rotWithShape="1">
+          <a:blip r:embed="rId3"/>
+          <a:srcRect t="1035"/>
+          <a:stretch/>
+        </p:blipFill>
+        <p:spPr>
+          <a:xfrm>
+            <a:off x="2374231" y="2122268"/>
+            <a:ext cx="6833937" cy="4235670"/>
+          </a:xfrm>
+          <a:prstGeom prst="rect">
+            <a:avLst/>
+          </a:prstGeom>
+        </p:spPr>
+      </p:pic>
+    </p:spTree>
+    <p:extLst>
+      <p:ext uri="{BB962C8B-B14F-4D97-AF65-F5344CB8AC3E}">
+        <p14:creationId xmlns:p14="http://schemas.microsoft.com/office/powerpoint/2010/main" val="3873336915"/>
+      </p:ext>
+    </p:extLst>
+  </p:cSld>
+  <p:clrMapOvr>
+    <a:masterClrMapping/>
+  </p:clrMapOvr>
+</p:sld>
+</file>
+
+<file path=ppt/slides/slide16.xml><?xml version="1.0" encoding="utf-8"?>
+<p:sld xmlns:a="http://schemas.openxmlformats.org/drawingml/2006/main" xmlns:r="http://schemas.openxmlformats.org/officeDocument/2006/relationships" xmlns:p="http://schemas.openxmlformats.org/presentationml/2006/main">
+  <p:cSld>
+    <p:spTree>
+      <p:nvGrpSpPr>
+        <p:cNvPr id="1" name=""/>
+        <p:cNvGrpSpPr/>
+        <p:nvPr/>
+      </p:nvGrpSpPr>
+      <p:grpSpPr>
+        <a:xfrm>
+          <a:off x="0" y="0"/>
+          <a:ext cx="0" cy="0"/>
+          <a:chOff x="0" y="0"/>
+          <a:chExt cx="0" cy="0"/>
+        </a:xfrm>
+      </p:grpSpPr>
+      <p:sp>
+        <p:nvSpPr>
+          <p:cNvPr id="2" name="Title 1">
+            <a:extLst>
+              <a:ext uri="{FF2B5EF4-FFF2-40B4-BE49-F238E27FC236}">
+                <a16:creationId xmlns:a16="http://schemas.microsoft.com/office/drawing/2014/main" id="{F416DC7E-97AD-43A4-A8F4-9BE488FA1053}"/>
+              </a:ext>
+            </a:extLst>
+          </p:cNvPr>
+          <p:cNvSpPr>
+            <a:spLocks noGrp="1"/>
+          </p:cNvSpPr>
+          <p:nvPr>
+            <p:ph type="title"/>
+          </p:nvPr>
+        </p:nvSpPr>
+        <p:spPr/>
+        <p:txBody>
+          <a:bodyPr/>
+          <a:lstStyle/>
+          <a:p>
+            <a:r>
+              <a:rPr lang="en-CA" dirty="0"/>
+              <a:t>Demand activates the no-show effect on utilization</a:t>
+            </a:r>
+          </a:p>
+        </p:txBody>
+      </p:sp>
+      <p:pic>
+        <p:nvPicPr>
+          <p:cNvPr id="5" name="Picture 4">
+            <a:extLst>
+              <a:ext uri="{FF2B5EF4-FFF2-40B4-BE49-F238E27FC236}">
+                <a16:creationId xmlns:a16="http://schemas.microsoft.com/office/drawing/2014/main" id="{059C0EAC-019C-4963-85BB-2E314EB0E167}"/>
+              </a:ext>
+            </a:extLst>
+          </p:cNvPr>
+          <p:cNvPicPr>
+            <a:picLocks noChangeAspect="1"/>
+          </p:cNvPicPr>
+          <p:nvPr/>
+        </p:nvPicPr>
+        <p:blipFill>
+          <a:blip r:embed="rId3"/>
+          <a:stretch>
+            <a:fillRect/>
+          </a:stretch>
+        </p:blipFill>
+        <p:spPr>
+          <a:xfrm>
+            <a:off x="2128530" y="1690688"/>
+            <a:ext cx="7304227" cy="4629795"/>
+          </a:xfrm>
+          <a:prstGeom prst="rect">
+            <a:avLst/>
+          </a:prstGeom>
+        </p:spPr>
+      </p:pic>
+    </p:spTree>
+    <p:extLst>
+      <p:ext uri="{BB962C8B-B14F-4D97-AF65-F5344CB8AC3E}">
+        <p14:creationId xmlns:p14="http://schemas.microsoft.com/office/powerpoint/2010/main" val="1479030415"/>
+      </p:ext>
+    </p:extLst>
+  </p:cSld>
+  <p:clrMapOvr>
+    <a:masterClrMapping/>
+  </p:clrMapOvr>
+</p:sld>
+</file>
+
+<file path=ppt/slides/slide17.xml><?xml version="1.0" encoding="utf-8"?>
+<p:sld xmlns:a="http://schemas.openxmlformats.org/drawingml/2006/main" xmlns:r="http://schemas.openxmlformats.org/officeDocument/2006/relationships" xmlns:p="http://schemas.openxmlformats.org/presentationml/2006/main">
+  <p:cSld>
+    <p:spTree>
+      <p:nvGrpSpPr>
+        <p:cNvPr id="1" name=""/>
+        <p:cNvGrpSpPr/>
+        <p:nvPr/>
+      </p:nvGrpSpPr>
+      <p:grpSpPr>
+        <a:xfrm>
+          <a:off x="0" y="0"/>
+          <a:ext cx="0" cy="0"/>
+          <a:chOff x="0" y="0"/>
+          <a:chExt cx="0" cy="0"/>
+        </a:xfrm>
+      </p:grpSpPr>
+      <p:sp>
+        <p:nvSpPr>
+          <p:cNvPr id="2" name="Title 1">
+            <a:extLst>
+              <a:ext uri="{FF2B5EF4-FFF2-40B4-BE49-F238E27FC236}">
+                <a16:creationId xmlns:a16="http://schemas.microsoft.com/office/drawing/2014/main" id="{0D045B51-3913-420F-8417-28692C8ED825}"/>
+              </a:ext>
+            </a:extLst>
+          </p:cNvPr>
+          <p:cNvSpPr>
+            <a:spLocks noGrp="1"/>
+          </p:cNvSpPr>
+          <p:nvPr>
+            <p:ph type="title"/>
+          </p:nvPr>
+        </p:nvSpPr>
+        <p:spPr/>
+        <p:txBody>
+          <a:bodyPr/>
+          <a:lstStyle/>
+          <a:p>
+            <a:r>
+              <a:rPr lang="en-CA" dirty="0"/>
+              <a:t>When optimizing utilization, horizon is usually cut short to prevent no-shows</a:t>
+            </a:r>
+          </a:p>
+        </p:txBody>
+      </p:sp>
+      <p:sp>
+        <p:nvSpPr>
+          <p:cNvPr id="3" name="Content Placeholder 2">
+            <a:extLst>
+              <a:ext uri="{FF2B5EF4-FFF2-40B4-BE49-F238E27FC236}">
+                <a16:creationId xmlns:a16="http://schemas.microsoft.com/office/drawing/2014/main" id="{E2DC23E4-8017-42D1-A28D-879146B6160B}"/>
+              </a:ext>
+            </a:extLst>
+          </p:cNvPr>
+          <p:cNvSpPr>
+            <a:spLocks noGrp="1"/>
+          </p:cNvSpPr>
+          <p:nvPr>
+            <p:ph idx="1"/>
+          </p:nvPr>
+        </p:nvSpPr>
+        <p:spPr/>
+        <p:txBody>
+          <a:bodyPr/>
+          <a:lstStyle/>
+          <a:p>
+            <a:endParaRPr lang="en-CA"/>
+          </a:p>
+        </p:txBody>
+      </p:sp>
+    </p:spTree>
+    <p:extLst>
+      <p:ext uri="{BB962C8B-B14F-4D97-AF65-F5344CB8AC3E}">
+        <p14:creationId xmlns:p14="http://schemas.microsoft.com/office/powerpoint/2010/main" val="2328307014"/>
+      </p:ext>
+    </p:extLst>
+  </p:cSld>
+  <p:clrMapOvr>
+    <a:masterClrMapping/>
+  </p:clrMapOvr>
+</p:sld>
+</file>
+
+<file path=ppt/slides/slide18.xml><?xml version="1.0" encoding="utf-8"?>
+<p:sld xmlns:a="http://schemas.openxmlformats.org/drawingml/2006/main" xmlns:r="http://schemas.openxmlformats.org/officeDocument/2006/relationships" xmlns:p="http://schemas.openxmlformats.org/presentationml/2006/main">
+  <p:cSld>
+    <p:spTree>
+      <p:nvGrpSpPr>
+        <p:cNvPr id="1" name=""/>
+        <p:cNvGrpSpPr/>
+        <p:nvPr/>
+      </p:nvGrpSpPr>
+      <p:grpSpPr>
+        <a:xfrm>
+          <a:off x="0" y="0"/>
+          <a:ext cx="0" cy="0"/>
+          <a:chOff x="0" y="0"/>
+          <a:chExt cx="0" cy="0"/>
+        </a:xfrm>
+      </p:grpSpPr>
+      <p:sp>
+        <p:nvSpPr>
+          <p:cNvPr id="2" name="Title 1">
+            <a:extLst>
+              <a:ext uri="{FF2B5EF4-FFF2-40B4-BE49-F238E27FC236}">
+                <a16:creationId xmlns:a16="http://schemas.microsoft.com/office/drawing/2014/main" id="{1C8EFFAE-FAAC-489E-940F-4BACE00C4D30}"/>
+              </a:ext>
+            </a:extLst>
+          </p:cNvPr>
+          <p:cNvSpPr>
+            <a:spLocks noGrp="1"/>
+          </p:cNvSpPr>
+          <p:nvPr>
+            <p:ph type="title"/>
+          </p:nvPr>
+        </p:nvSpPr>
+        <p:spPr/>
+        <p:txBody>
+          <a:bodyPr/>
+          <a:lstStyle/>
+          <a:p>
+            <a:r>
+              <a:rPr lang="en-CA" dirty="0"/>
+              <a:t>When does reservation policy not hurt the other class?</a:t>
+            </a:r>
+          </a:p>
+        </p:txBody>
+      </p:sp>
+      <p:sp>
+        <p:nvSpPr>
+          <p:cNvPr id="3" name="Content Placeholder 2">
+            <a:extLst>
+              <a:ext uri="{FF2B5EF4-FFF2-40B4-BE49-F238E27FC236}">
+                <a16:creationId xmlns:a16="http://schemas.microsoft.com/office/drawing/2014/main" id="{F9C6B679-2893-47B0-B1C7-B701E0D57F4E}"/>
+              </a:ext>
+            </a:extLst>
+          </p:cNvPr>
+          <p:cNvSpPr>
+            <a:spLocks noGrp="1"/>
+          </p:cNvSpPr>
+          <p:nvPr>
+            <p:ph idx="1"/>
+          </p:nvPr>
+        </p:nvSpPr>
+        <p:spPr/>
+        <p:txBody>
+          <a:bodyPr/>
+          <a:lstStyle/>
+          <a:p>
+            <a:pPr marL="0" indent="0">
+              <a:buNone/>
+            </a:pPr>
+            <a:r>
+              <a:rPr lang="en-CA" dirty="0"/>
+              <a:t>Let Class 1 be the reservation class</a:t>
+            </a:r>
+          </a:p>
+          <a:p>
+            <a:endParaRPr lang="en-CA" dirty="0"/>
+          </a:p>
+          <a:p>
+            <a:r>
+              <a:rPr lang="en-CA" dirty="0"/>
+              <a:t>When Class 1 is a smaller portion of the queueing population</a:t>
+            </a:r>
+          </a:p>
+          <a:p>
+            <a:r>
+              <a:rPr lang="en-CA" dirty="0"/>
+              <a:t>When demand is lower</a:t>
+            </a:r>
+          </a:p>
+          <a:p>
+            <a:r>
+              <a:rPr lang="en-CA" dirty="0"/>
+              <a:t>When no-show magnitude is not too high</a:t>
+            </a:r>
+          </a:p>
+        </p:txBody>
+      </p:sp>
+    </p:spTree>
+    <p:extLst>
+      <p:ext uri="{BB962C8B-B14F-4D97-AF65-F5344CB8AC3E}">
+        <p14:creationId xmlns:p14="http://schemas.microsoft.com/office/powerpoint/2010/main" val="543504394"/>
       </p:ext>
     </p:extLst>
   </p:cSld>
@@ -6197,7 +6959,7 @@
           <p:cNvPr id="2" name="Title 1">
             <a:extLst>
               <a:ext uri="{FF2B5EF4-FFF2-40B4-BE49-F238E27FC236}">
-                <a16:creationId xmlns:a16="http://schemas.microsoft.com/office/drawing/2014/main" id="{8123D558-104E-46B9-A53B-CC248BF90AEC}"/>
+                <a16:creationId xmlns:a16="http://schemas.microsoft.com/office/drawing/2014/main" id="{A21633CC-5640-40DD-82F7-8C55D31A5E8D}"/>
               </a:ext>
             </a:extLst>
           </p:cNvPr>
@@ -6210,41 +6972,70 @@
         </p:nvSpPr>
         <p:spPr>
           <a:xfrm>
-            <a:off x="927719" y="321438"/>
-            <a:ext cx="11024364" cy="1325563"/>
+            <a:off x="551442" y="124493"/>
+            <a:ext cx="10515600" cy="1325563"/>
           </a:xfrm>
         </p:spPr>
         <p:txBody>
-          <a:bodyPr>
-            <a:normAutofit/>
-          </a:bodyPr>
-          <a:lstStyle/>
-          <a:p>
-            <a:r>
-              <a:rPr lang="en-CA" sz="4000" dirty="0"/>
-              <a:t>Demand is a big driver of served rate compounded by no-show</a:t>
+          <a:bodyPr/>
+          <a:lstStyle/>
+          <a:p>
+            <a:r>
+              <a:rPr lang="en-CA" dirty="0"/>
+              <a:t>Threshold mechanisms: magnitude and delay </a:t>
+            </a:r>
+          </a:p>
+        </p:txBody>
+      </p:sp>
+      <p:sp>
+        <p:nvSpPr>
+          <p:cNvPr id="3" name="Content Placeholder 2">
+            <a:extLst>
+              <a:ext uri="{FF2B5EF4-FFF2-40B4-BE49-F238E27FC236}">
+                <a16:creationId xmlns:a16="http://schemas.microsoft.com/office/drawing/2014/main" id="{F4D00A5A-4B37-44F0-B338-F679E868F683}"/>
+              </a:ext>
+            </a:extLst>
+          </p:cNvPr>
+          <p:cNvSpPr>
+            <a:spLocks noGrp="1"/>
+          </p:cNvSpPr>
+          <p:nvPr>
+            <p:ph idx="1"/>
+          </p:nvPr>
+        </p:nvSpPr>
+        <p:spPr>
+          <a:xfrm>
+            <a:off x="1124958" y="1258552"/>
+            <a:ext cx="10515600" cy="683544"/>
+          </a:xfrm>
+        </p:spPr>
+        <p:txBody>
+          <a:bodyPr/>
+          <a:lstStyle/>
+          <a:p>
+            <a:r>
+              <a:rPr lang="en-CA" dirty="0"/>
+              <a:t>For both no-show and balking behavior of both classes</a:t>
             </a:r>
           </a:p>
         </p:txBody>
       </p:sp>
       <p:pic>
         <p:nvPicPr>
-          <p:cNvPr id="5" name="Content Placeholder 4">
+          <p:cNvPr id="5" name="Picture 4">
             <a:extLst>
               <a:ext uri="{FF2B5EF4-FFF2-40B4-BE49-F238E27FC236}">
-                <a16:creationId xmlns:a16="http://schemas.microsoft.com/office/drawing/2014/main" id="{E6106BE1-806D-4B56-8473-297C61BC03B6}"/>
+                <a16:creationId xmlns:a16="http://schemas.microsoft.com/office/drawing/2014/main" id="{BD12449E-5E0B-4C76-AA28-4C90FDDE410E}"/>
               </a:ext>
             </a:extLst>
           </p:cNvPr>
           <p:cNvPicPr>
-            <a:picLocks noGrp="1" noChangeAspect="1"/>
+            <a:picLocks noChangeAspect="1"/>
           </p:cNvPicPr>
-          <p:nvPr>
-            <p:ph idx="1"/>
-          </p:nvPr>
+          <p:nvPr/>
         </p:nvPicPr>
         <p:blipFill>
-          <a:blip r:embed="rId3">
+          <a:blip r:embed="rId2">
             <a:extLst>
               <a:ext uri="{28A0092B-C50C-407E-A947-70E740481C1C}">
                 <a14:useLocalDpi xmlns:a14="http://schemas.microsoft.com/office/drawing/2010/main" val="0"/>
@@ -6257,47 +7048,79 @@
         </p:blipFill>
         <p:spPr>
           <a:xfrm>
-            <a:off x="121025" y="1742639"/>
-            <a:ext cx="5856083" cy="3773920"/>
-          </a:xfrm>
-        </p:spPr>
-      </p:pic>
-      <p:pic>
-        <p:nvPicPr>
-          <p:cNvPr id="7" name="Picture 6">
-            <a:extLst>
-              <a:ext uri="{FF2B5EF4-FFF2-40B4-BE49-F238E27FC236}">
-                <a16:creationId xmlns:a16="http://schemas.microsoft.com/office/drawing/2014/main" id="{01C42C6A-656B-42A0-86A9-43C62713C453}"/>
-              </a:ext>
-            </a:extLst>
-          </p:cNvPr>
-          <p:cNvPicPr>
-            <a:picLocks noChangeAspect="1"/>
-          </p:cNvPicPr>
-          <p:nvPr/>
-        </p:nvPicPr>
-        <p:blipFill>
-          <a:blip r:embed="rId4">
-            <a:extLst>
-              <a:ext uri="{28A0092B-C50C-407E-A947-70E740481C1C}">
-                <a14:useLocalDpi xmlns:a14="http://schemas.microsoft.com/office/drawing/2010/main" val="0"/>
-              </a:ext>
-            </a:extLst>
-          </a:blip>
-          <a:stretch>
-            <a:fillRect/>
-          </a:stretch>
-        </p:blipFill>
-        <p:spPr>
-          <a:xfrm>
-            <a:off x="6096000" y="1742638"/>
-            <a:ext cx="5856083" cy="3773921"/>
+            <a:off x="1552064" y="1942096"/>
+            <a:ext cx="8514356" cy="4490203"/>
           </a:xfrm>
           <a:prstGeom prst="rect">
             <a:avLst/>
           </a:prstGeom>
         </p:spPr>
       </p:pic>
+    </p:spTree>
+    <p:extLst>
+      <p:ext uri="{BB962C8B-B14F-4D97-AF65-F5344CB8AC3E}">
+        <p14:creationId xmlns:p14="http://schemas.microsoft.com/office/powerpoint/2010/main" val="2806244447"/>
+      </p:ext>
+    </p:extLst>
+  </p:cSld>
+  <p:clrMapOvr>
+    <a:masterClrMapping/>
+  </p:clrMapOvr>
+</p:sld>
+</file>
+
+<file path=ppt/slides/slide6.xml><?xml version="1.0" encoding="utf-8"?>
+<p:sld xmlns:a="http://schemas.openxmlformats.org/drawingml/2006/main" xmlns:r="http://schemas.openxmlformats.org/officeDocument/2006/relationships" xmlns:p="http://schemas.openxmlformats.org/presentationml/2006/main">
+  <p:cSld>
+    <p:spTree>
+      <p:nvGrpSpPr>
+        <p:cNvPr id="1" name=""/>
+        <p:cNvGrpSpPr/>
+        <p:nvPr/>
+      </p:nvGrpSpPr>
+      <p:grpSpPr>
+        <a:xfrm>
+          <a:off x="0" y="0"/>
+          <a:ext cx="0" cy="0"/>
+          <a:chOff x="0" y="0"/>
+          <a:chExt cx="0" cy="0"/>
+        </a:xfrm>
+      </p:grpSpPr>
+      <p:sp>
+        <p:nvSpPr>
+          <p:cNvPr id="2" name="Title 1">
+            <a:extLst>
+              <a:ext uri="{FF2B5EF4-FFF2-40B4-BE49-F238E27FC236}">
+                <a16:creationId xmlns:a16="http://schemas.microsoft.com/office/drawing/2014/main" id="{8123D558-104E-46B9-A53B-CC248BF90AEC}"/>
+              </a:ext>
+            </a:extLst>
+          </p:cNvPr>
+          <p:cNvSpPr>
+            <a:spLocks noGrp="1"/>
+          </p:cNvSpPr>
+          <p:nvPr>
+            <p:ph type="title"/>
+          </p:nvPr>
+        </p:nvSpPr>
+        <p:spPr>
+          <a:xfrm>
+            <a:off x="927719" y="321438"/>
+            <a:ext cx="11024364" cy="1325563"/>
+          </a:xfrm>
+        </p:spPr>
+        <p:txBody>
+          <a:bodyPr>
+            <a:normAutofit/>
+          </a:bodyPr>
+          <a:lstStyle/>
+          <a:p>
+            <a:r>
+              <a:rPr lang="en-CA" sz="4000" dirty="0"/>
+              <a:t>Demand is a big driver of served rate compounded by no-show</a:t>
+            </a:r>
+          </a:p>
+        </p:txBody>
+      </p:sp>
       <p:sp>
         <p:nvSpPr>
           <p:cNvPr id="6" name="Content Placeholder 2">
@@ -6314,7 +7137,7 @@
         </p:nvSpPr>
         <p:spPr>
           <a:xfrm>
-            <a:off x="687802" y="5612196"/>
+            <a:off x="463859" y="5584764"/>
             <a:ext cx="11264281" cy="1136061"/>
           </a:xfrm>
           <a:prstGeom prst="rect">
@@ -6323,7 +7146,7 @@
         </p:spPr>
         <p:txBody>
           <a:bodyPr vert="horz" lIns="91440" tIns="45720" rIns="91440" bIns="45720" rtlCol="0">
-            <a:normAutofit fontScale="92500"/>
+            <a:normAutofit fontScale="92500" lnSpcReduction="20000"/>
           </a:bodyPr>
           <a:lstStyle>
             <a:lvl1pPr marL="228600" indent="-228600" algn="l" defTabSz="914400" rtl="0" eaLnBrk="1" latinLnBrk="0" hangingPunct="1">
@@ -6498,107 +7321,86 @@
           <a:p>
             <a:r>
               <a:rPr lang="en-CA" dirty="0"/>
-              <a:t>Balking rate has minimal effects while no-show further drives down served rate.</a:t>
-            </a:r>
-          </a:p>
-        </p:txBody>
-      </p:sp>
+              <a:t>Balking rate has minimal effect while an increase in no-show magnitude further drives down served rate.</a:t>
+            </a:r>
+          </a:p>
+        </p:txBody>
+      </p:sp>
+      <p:pic>
+        <p:nvPicPr>
+          <p:cNvPr id="9" name="Content Placeholder 8">
+            <a:extLst>
+              <a:ext uri="{FF2B5EF4-FFF2-40B4-BE49-F238E27FC236}">
+                <a16:creationId xmlns:a16="http://schemas.microsoft.com/office/drawing/2014/main" id="{EA07281E-6E5D-46F7-ADDC-8584EE6A46F7}"/>
+              </a:ext>
+            </a:extLst>
+          </p:cNvPr>
+          <p:cNvPicPr>
+            <a:picLocks noGrp="1" noChangeAspect="1"/>
+          </p:cNvPicPr>
+          <p:nvPr>
+            <p:ph idx="1"/>
+          </p:nvPr>
+        </p:nvPicPr>
+        <p:blipFill>
+          <a:blip r:embed="rId3">
+            <a:extLst>
+              <a:ext uri="{28A0092B-C50C-407E-A947-70E740481C1C}">
+                <a14:useLocalDpi xmlns:a14="http://schemas.microsoft.com/office/drawing/2010/main" val="0"/>
+              </a:ext>
+            </a:extLst>
+          </a:blip>
+          <a:stretch>
+            <a:fillRect/>
+          </a:stretch>
+        </p:blipFill>
+        <p:spPr>
+          <a:xfrm>
+            <a:off x="416703" y="1812702"/>
+            <a:ext cx="5400261" cy="3403452"/>
+          </a:xfrm>
+        </p:spPr>
+      </p:pic>
+      <p:pic>
+        <p:nvPicPr>
+          <p:cNvPr id="13" name="Picture 12">
+            <a:extLst>
+              <a:ext uri="{FF2B5EF4-FFF2-40B4-BE49-F238E27FC236}">
+                <a16:creationId xmlns:a16="http://schemas.microsoft.com/office/drawing/2014/main" id="{6A325E58-3055-4045-B165-07194A78D8E9}"/>
+              </a:ext>
+            </a:extLst>
+          </p:cNvPr>
+          <p:cNvPicPr>
+            <a:picLocks noChangeAspect="1"/>
+          </p:cNvPicPr>
+          <p:nvPr/>
+        </p:nvPicPr>
+        <p:blipFill>
+          <a:blip r:embed="rId4">
+            <a:extLst>
+              <a:ext uri="{28A0092B-C50C-407E-A947-70E740481C1C}">
+                <a14:useLocalDpi xmlns:a14="http://schemas.microsoft.com/office/drawing/2010/main" val="0"/>
+              </a:ext>
+            </a:extLst>
+          </a:blip>
+          <a:stretch>
+            <a:fillRect/>
+          </a:stretch>
+        </p:blipFill>
+        <p:spPr>
+          <a:xfrm>
+            <a:off x="5990700" y="1641844"/>
+            <a:ext cx="5671360" cy="3574309"/>
+          </a:xfrm>
+          <a:prstGeom prst="rect">
+            <a:avLst/>
+          </a:prstGeom>
+        </p:spPr>
+      </p:pic>
     </p:spTree>
     <p:extLst>
       <p:ext uri="{BB962C8B-B14F-4D97-AF65-F5344CB8AC3E}">
         <p14:creationId xmlns:p14="http://schemas.microsoft.com/office/powerpoint/2010/main" val="3359586173"/>
-      </p:ext>
-    </p:extLst>
-  </p:cSld>
-  <p:clrMapOvr>
-    <a:masterClrMapping/>
-  </p:clrMapOvr>
-</p:sld>
-</file>
-
-<file path=ppt/slides/slide6.xml><?xml version="1.0" encoding="utf-8"?>
-<p:sld xmlns:a="http://schemas.openxmlformats.org/drawingml/2006/main" xmlns:r="http://schemas.openxmlformats.org/officeDocument/2006/relationships" xmlns:p="http://schemas.openxmlformats.org/presentationml/2006/main">
-  <p:cSld>
-    <p:spTree>
-      <p:nvGrpSpPr>
-        <p:cNvPr id="1" name=""/>
-        <p:cNvGrpSpPr/>
-        <p:nvPr/>
-      </p:nvGrpSpPr>
-      <p:grpSpPr>
-        <a:xfrm>
-          <a:off x="0" y="0"/>
-          <a:ext cx="0" cy="0"/>
-          <a:chOff x="0" y="0"/>
-          <a:chExt cx="0" cy="0"/>
-        </a:xfrm>
-      </p:grpSpPr>
-      <p:sp>
-        <p:nvSpPr>
-          <p:cNvPr id="2" name="Title 1">
-            <a:extLst>
-              <a:ext uri="{FF2B5EF4-FFF2-40B4-BE49-F238E27FC236}">
-                <a16:creationId xmlns:a16="http://schemas.microsoft.com/office/drawing/2014/main" id="{A21633CC-5640-40DD-82F7-8C55D31A5E8D}"/>
-              </a:ext>
-            </a:extLst>
-          </p:cNvPr>
-          <p:cNvSpPr>
-            <a:spLocks noGrp="1"/>
-          </p:cNvSpPr>
-          <p:nvPr>
-            <p:ph type="title"/>
-          </p:nvPr>
-        </p:nvSpPr>
-        <p:spPr/>
-        <p:txBody>
-          <a:bodyPr/>
-          <a:lstStyle/>
-          <a:p>
-            <a:r>
-              <a:rPr lang="en-CA" dirty="0"/>
-              <a:t>Threshold mechanisms: magnitude and delay </a:t>
-            </a:r>
-          </a:p>
-        </p:txBody>
-      </p:sp>
-      <p:sp>
-        <p:nvSpPr>
-          <p:cNvPr id="3" name="Content Placeholder 2">
-            <a:extLst>
-              <a:ext uri="{FF2B5EF4-FFF2-40B4-BE49-F238E27FC236}">
-                <a16:creationId xmlns:a16="http://schemas.microsoft.com/office/drawing/2014/main" id="{F4D00A5A-4B37-44F0-B338-F679E868F683}"/>
-              </a:ext>
-            </a:extLst>
-          </p:cNvPr>
-          <p:cNvSpPr>
-            <a:spLocks noGrp="1"/>
-          </p:cNvSpPr>
-          <p:nvPr>
-            <p:ph idx="1"/>
-          </p:nvPr>
-        </p:nvSpPr>
-        <p:spPr/>
-        <p:txBody>
-          <a:bodyPr/>
-          <a:lstStyle/>
-          <a:p>
-            <a:r>
-              <a:rPr lang="en-CA" dirty="0"/>
-              <a:t>For both no-show and balking behavior of both classes</a:t>
-            </a:r>
-          </a:p>
-          <a:p>
-            <a:r>
-              <a:rPr lang="en-CA" dirty="0"/>
-              <a:t>Magnitude and delay for probability and threshold</a:t>
-            </a:r>
-          </a:p>
-        </p:txBody>
-      </p:sp>
-    </p:spTree>
-    <p:extLst>
-      <p:ext uri="{BB962C8B-B14F-4D97-AF65-F5344CB8AC3E}">
-        <p14:creationId xmlns:p14="http://schemas.microsoft.com/office/powerpoint/2010/main" val="2806244447"/>
       </p:ext>
     </p:extLst>
   </p:cSld>
@@ -6867,10 +7669,10 @@
       </p:sp>
       <p:pic>
         <p:nvPicPr>
-          <p:cNvPr id="9" name="Content Placeholder 8">
+          <p:cNvPr id="13" name="Content Placeholder 12">
             <a:extLst>
               <a:ext uri="{FF2B5EF4-FFF2-40B4-BE49-F238E27FC236}">
-                <a16:creationId xmlns:a16="http://schemas.microsoft.com/office/drawing/2014/main" id="{CEDCDF1F-1F72-4580-9C83-11BF5DD5BF62}"/>
+                <a16:creationId xmlns:a16="http://schemas.microsoft.com/office/drawing/2014/main" id="{8BBDB6B9-A299-4D1A-8014-E1BF9DAF6F7D}"/>
               </a:ext>
             </a:extLst>
           </p:cNvPr>
@@ -6895,17 +7697,17 @@
         </p:blipFill>
         <p:spPr>
           <a:xfrm>
-            <a:off x="249309" y="1742073"/>
-            <a:ext cx="6142491" cy="3541945"/>
+            <a:off x="371977" y="1703951"/>
+            <a:ext cx="5724023" cy="3607499"/>
           </a:xfrm>
         </p:spPr>
       </p:pic>
       <p:pic>
         <p:nvPicPr>
-          <p:cNvPr id="11" name="Picture 10">
+          <p:cNvPr id="15" name="Picture 14">
             <a:extLst>
               <a:ext uri="{FF2B5EF4-FFF2-40B4-BE49-F238E27FC236}">
-                <a16:creationId xmlns:a16="http://schemas.microsoft.com/office/drawing/2014/main" id="{519762D0-E7D8-4F88-AA38-383BD0469110}"/>
+                <a16:creationId xmlns:a16="http://schemas.microsoft.com/office/drawing/2014/main" id="{E81811C4-4438-442A-AC72-A8CED8D9BD11}"/>
               </a:ext>
             </a:extLst>
           </p:cNvPr>
@@ -6914,7 +7716,7 @@
           </p:cNvPicPr>
           <p:nvPr/>
         </p:nvPicPr>
-        <p:blipFill rotWithShape="1">
+        <p:blipFill>
           <a:blip r:embed="rId4">
             <a:extLst>
               <a:ext uri="{28A0092B-C50C-407E-A947-70E740481C1C}">
@@ -6922,13 +7724,14 @@
               </a:ext>
             </a:extLst>
           </a:blip>
-          <a:srcRect r="11396"/>
-          <a:stretch/>
+          <a:stretch>
+            <a:fillRect/>
+          </a:stretch>
         </p:blipFill>
         <p:spPr>
           <a:xfrm>
-            <a:off x="6455952" y="1742073"/>
-            <a:ext cx="5442493" cy="3541945"/>
+            <a:off x="6096000" y="1703951"/>
+            <a:ext cx="5724024" cy="3607499"/>
           </a:xfrm>
           <a:prstGeom prst="rect">
             <a:avLst/>
@@ -7068,10 +7871,10 @@
       </p:sp>
       <p:pic>
         <p:nvPicPr>
-          <p:cNvPr id="5" name="Picture 4">
+          <p:cNvPr id="9" name="Picture 8">
             <a:extLst>
               <a:ext uri="{FF2B5EF4-FFF2-40B4-BE49-F238E27FC236}">
-                <a16:creationId xmlns:a16="http://schemas.microsoft.com/office/drawing/2014/main" id="{6C2A9535-274A-454B-9DAA-7E08D3CD105A}"/>
+                <a16:creationId xmlns:a16="http://schemas.microsoft.com/office/drawing/2014/main" id="{ECA8BDFE-1BF3-4206-B4F7-C70774685188}"/>
               </a:ext>
             </a:extLst>
           </p:cNvPr>
@@ -7080,15 +7883,22 @@
           </p:cNvPicPr>
           <p:nvPr/>
         </p:nvPicPr>
-        <p:blipFill rotWithShape="1">
-          <a:blip r:embed="rId2"/>
-          <a:srcRect t="6612"/>
-          <a:stretch/>
+        <p:blipFill>
+          <a:blip r:embed="rId2">
+            <a:extLst>
+              <a:ext uri="{28A0092B-C50C-407E-A947-70E740481C1C}">
+                <a14:useLocalDpi xmlns:a14="http://schemas.microsoft.com/office/drawing/2010/main" val="0"/>
+              </a:ext>
+            </a:extLst>
+          </a:blip>
+          <a:stretch>
+            <a:fillRect/>
+          </a:stretch>
         </p:blipFill>
         <p:spPr>
           <a:xfrm>
-            <a:off x="485496" y="2094534"/>
-            <a:ext cx="5380594" cy="3223470"/>
+            <a:off x="244522" y="1828805"/>
+            <a:ext cx="5673194" cy="3575465"/>
           </a:xfrm>
           <a:prstGeom prst="rect">
             <a:avLst/>
@@ -7097,10 +7907,10 @@
       </p:pic>
       <p:pic>
         <p:nvPicPr>
-          <p:cNvPr id="7" name="Picture 6">
+          <p:cNvPr id="11" name="Picture 10">
             <a:extLst>
               <a:ext uri="{FF2B5EF4-FFF2-40B4-BE49-F238E27FC236}">
-                <a16:creationId xmlns:a16="http://schemas.microsoft.com/office/drawing/2014/main" id="{7629A7A0-8C4A-4DBC-97BB-2AF62F9E42DE}"/>
+                <a16:creationId xmlns:a16="http://schemas.microsoft.com/office/drawing/2014/main" id="{0983DFAC-3F4A-46F9-97E5-0E86633BCF41}"/>
               </a:ext>
             </a:extLst>
           </p:cNvPr>
@@ -7109,425 +7919,28 @@
           </p:cNvPicPr>
           <p:nvPr/>
         </p:nvPicPr>
-        <p:blipFill rotWithShape="1">
-          <a:blip r:embed="rId3"/>
-          <a:srcRect t="6997"/>
-          <a:stretch/>
+        <p:blipFill>
+          <a:blip r:embed="rId3">
+            <a:extLst>
+              <a:ext uri="{28A0092B-C50C-407E-A947-70E740481C1C}">
+                <a14:useLocalDpi xmlns:a14="http://schemas.microsoft.com/office/drawing/2010/main" val="0"/>
+              </a:ext>
+            </a:extLst>
+          </a:blip>
+          <a:stretch>
+            <a:fillRect/>
+          </a:stretch>
         </p:blipFill>
         <p:spPr>
           <a:xfrm>
-            <a:off x="6096000" y="2058056"/>
-            <a:ext cx="5380594" cy="3289927"/>
+            <a:off x="5917716" y="1716444"/>
+            <a:ext cx="5851478" cy="3687826"/>
           </a:xfrm>
           <a:prstGeom prst="rect">
             <a:avLst/>
           </a:prstGeom>
         </p:spPr>
       </p:pic>
-      <p:sp>
-        <p:nvSpPr>
-          <p:cNvPr id="6" name="Content Placeholder 2">
-            <a:extLst>
-              <a:ext uri="{FF2B5EF4-FFF2-40B4-BE49-F238E27FC236}">
-                <a16:creationId xmlns:a16="http://schemas.microsoft.com/office/drawing/2014/main" id="{21956235-D240-493B-B123-002E69B01EB2}"/>
-              </a:ext>
-            </a:extLst>
-          </p:cNvPr>
-          <p:cNvSpPr txBox="1">
-            <a:spLocks/>
-          </p:cNvSpPr>
-          <p:nvPr/>
-        </p:nvSpPr>
-        <p:spPr>
-          <a:xfrm>
-            <a:off x="7814813" y="1660707"/>
-            <a:ext cx="2618342" cy="662742"/>
-          </a:xfrm>
-          <a:prstGeom prst="rect">
-            <a:avLst/>
-          </a:prstGeom>
-        </p:spPr>
-        <p:txBody>
-          <a:bodyPr vert="horz" lIns="91440" tIns="45720" rIns="91440" bIns="45720" rtlCol="0">
-            <a:normAutofit/>
-          </a:bodyPr>
-          <a:lstStyle>
-            <a:lvl1pPr marL="228600" indent="-228600" algn="l" defTabSz="914400" rtl="0" eaLnBrk="1" latinLnBrk="0" hangingPunct="1">
-              <a:lnSpc>
-                <a:spcPct val="90000"/>
-              </a:lnSpc>
-              <a:spcBef>
-                <a:spcPts val="1000"/>
-              </a:spcBef>
-              <a:buFont typeface="Arial" panose="020B0604020202020204" pitchFamily="34" charset="0"/>
-              <a:buChar char="•"/>
-              <a:defRPr sz="2800" kern="1200">
-                <a:solidFill>
-                  <a:schemeClr val="tx1"/>
-                </a:solidFill>
-                <a:latin typeface="+mn-lt"/>
-                <a:ea typeface="+mn-ea"/>
-                <a:cs typeface="+mn-cs"/>
-              </a:defRPr>
-            </a:lvl1pPr>
-            <a:lvl2pPr marL="685800" indent="-228600" algn="l" defTabSz="914400" rtl="0" eaLnBrk="1" latinLnBrk="0" hangingPunct="1">
-              <a:lnSpc>
-                <a:spcPct val="90000"/>
-              </a:lnSpc>
-              <a:spcBef>
-                <a:spcPts val="500"/>
-              </a:spcBef>
-              <a:buFont typeface="Arial" panose="020B0604020202020204" pitchFamily="34" charset="0"/>
-              <a:buChar char="•"/>
-              <a:defRPr sz="2400" kern="1200">
-                <a:solidFill>
-                  <a:schemeClr val="tx1"/>
-                </a:solidFill>
-                <a:latin typeface="+mn-lt"/>
-                <a:ea typeface="+mn-ea"/>
-                <a:cs typeface="+mn-cs"/>
-              </a:defRPr>
-            </a:lvl2pPr>
-            <a:lvl3pPr marL="1143000" indent="-228600" algn="l" defTabSz="914400" rtl="0" eaLnBrk="1" latinLnBrk="0" hangingPunct="1">
-              <a:lnSpc>
-                <a:spcPct val="90000"/>
-              </a:lnSpc>
-              <a:spcBef>
-                <a:spcPts val="500"/>
-              </a:spcBef>
-              <a:buFont typeface="Arial" panose="020B0604020202020204" pitchFamily="34" charset="0"/>
-              <a:buChar char="•"/>
-              <a:defRPr sz="2000" kern="1200">
-                <a:solidFill>
-                  <a:schemeClr val="tx1"/>
-                </a:solidFill>
-                <a:latin typeface="+mn-lt"/>
-                <a:ea typeface="+mn-ea"/>
-                <a:cs typeface="+mn-cs"/>
-              </a:defRPr>
-            </a:lvl3pPr>
-            <a:lvl4pPr marL="1600200" indent="-228600" algn="l" defTabSz="914400" rtl="0" eaLnBrk="1" latinLnBrk="0" hangingPunct="1">
-              <a:lnSpc>
-                <a:spcPct val="90000"/>
-              </a:lnSpc>
-              <a:spcBef>
-                <a:spcPts val="500"/>
-              </a:spcBef>
-              <a:buFont typeface="Arial" panose="020B0604020202020204" pitchFamily="34" charset="0"/>
-              <a:buChar char="•"/>
-              <a:defRPr sz="1800" kern="1200">
-                <a:solidFill>
-                  <a:schemeClr val="tx1"/>
-                </a:solidFill>
-                <a:latin typeface="+mn-lt"/>
-                <a:ea typeface="+mn-ea"/>
-                <a:cs typeface="+mn-cs"/>
-              </a:defRPr>
-            </a:lvl4pPr>
-            <a:lvl5pPr marL="2057400" indent="-228600" algn="l" defTabSz="914400" rtl="0" eaLnBrk="1" latinLnBrk="0" hangingPunct="1">
-              <a:lnSpc>
-                <a:spcPct val="90000"/>
-              </a:lnSpc>
-              <a:spcBef>
-                <a:spcPts val="500"/>
-              </a:spcBef>
-              <a:buFont typeface="Arial" panose="020B0604020202020204" pitchFamily="34" charset="0"/>
-              <a:buChar char="•"/>
-              <a:defRPr sz="1800" kern="1200">
-                <a:solidFill>
-                  <a:schemeClr val="tx1"/>
-                </a:solidFill>
-                <a:latin typeface="+mn-lt"/>
-                <a:ea typeface="+mn-ea"/>
-                <a:cs typeface="+mn-cs"/>
-              </a:defRPr>
-            </a:lvl5pPr>
-            <a:lvl6pPr marL="2514600" indent="-228600" algn="l" defTabSz="914400" rtl="0" eaLnBrk="1" latinLnBrk="0" hangingPunct="1">
-              <a:lnSpc>
-                <a:spcPct val="90000"/>
-              </a:lnSpc>
-              <a:spcBef>
-                <a:spcPts val="500"/>
-              </a:spcBef>
-              <a:buFont typeface="Arial" panose="020B0604020202020204" pitchFamily="34" charset="0"/>
-              <a:buChar char="•"/>
-              <a:defRPr sz="1800" kern="1200">
-                <a:solidFill>
-                  <a:schemeClr val="tx1"/>
-                </a:solidFill>
-                <a:latin typeface="+mn-lt"/>
-                <a:ea typeface="+mn-ea"/>
-                <a:cs typeface="+mn-cs"/>
-              </a:defRPr>
-            </a:lvl6pPr>
-            <a:lvl7pPr marL="2971800" indent="-228600" algn="l" defTabSz="914400" rtl="0" eaLnBrk="1" latinLnBrk="0" hangingPunct="1">
-              <a:lnSpc>
-                <a:spcPct val="90000"/>
-              </a:lnSpc>
-              <a:spcBef>
-                <a:spcPts val="500"/>
-              </a:spcBef>
-              <a:buFont typeface="Arial" panose="020B0604020202020204" pitchFamily="34" charset="0"/>
-              <a:buChar char="•"/>
-              <a:defRPr sz="1800" kern="1200">
-                <a:solidFill>
-                  <a:schemeClr val="tx1"/>
-                </a:solidFill>
-                <a:latin typeface="+mn-lt"/>
-                <a:ea typeface="+mn-ea"/>
-                <a:cs typeface="+mn-cs"/>
-              </a:defRPr>
-            </a:lvl7pPr>
-            <a:lvl8pPr marL="3429000" indent="-228600" algn="l" defTabSz="914400" rtl="0" eaLnBrk="1" latinLnBrk="0" hangingPunct="1">
-              <a:lnSpc>
-                <a:spcPct val="90000"/>
-              </a:lnSpc>
-              <a:spcBef>
-                <a:spcPts val="500"/>
-              </a:spcBef>
-              <a:buFont typeface="Arial" panose="020B0604020202020204" pitchFamily="34" charset="0"/>
-              <a:buChar char="•"/>
-              <a:defRPr sz="1800" kern="1200">
-                <a:solidFill>
-                  <a:schemeClr val="tx1"/>
-                </a:solidFill>
-                <a:latin typeface="+mn-lt"/>
-                <a:ea typeface="+mn-ea"/>
-                <a:cs typeface="+mn-cs"/>
-              </a:defRPr>
-            </a:lvl8pPr>
-            <a:lvl9pPr marL="3886200" indent="-228600" algn="l" defTabSz="914400" rtl="0" eaLnBrk="1" latinLnBrk="0" hangingPunct="1">
-              <a:lnSpc>
-                <a:spcPct val="90000"/>
-              </a:lnSpc>
-              <a:spcBef>
-                <a:spcPts val="500"/>
-              </a:spcBef>
-              <a:buFont typeface="Arial" panose="020B0604020202020204" pitchFamily="34" charset="0"/>
-              <a:buChar char="•"/>
-              <a:defRPr sz="1800" kern="1200">
-                <a:solidFill>
-                  <a:schemeClr val="tx1"/>
-                </a:solidFill>
-                <a:latin typeface="+mn-lt"/>
-                <a:ea typeface="+mn-ea"/>
-                <a:cs typeface="+mn-cs"/>
-              </a:defRPr>
-            </a:lvl9pPr>
-          </a:lstStyle>
-          <a:p>
-            <a:pPr marL="0" indent="0">
-              <a:buNone/>
-            </a:pPr>
-            <a:r>
-              <a:rPr lang="en-CA" sz="1800" dirty="0"/>
-              <a:t>Delay – threshold</a:t>
-            </a:r>
-          </a:p>
-        </p:txBody>
-      </p:sp>
-      <p:sp>
-        <p:nvSpPr>
-          <p:cNvPr id="8" name="Content Placeholder 2">
-            <a:extLst>
-              <a:ext uri="{FF2B5EF4-FFF2-40B4-BE49-F238E27FC236}">
-                <a16:creationId xmlns:a16="http://schemas.microsoft.com/office/drawing/2014/main" id="{BB61C4F8-76CE-4AAA-9256-D4F8DD4F59FA}"/>
-              </a:ext>
-            </a:extLst>
-          </p:cNvPr>
-          <p:cNvSpPr txBox="1">
-            <a:spLocks/>
-          </p:cNvSpPr>
-          <p:nvPr/>
-        </p:nvSpPr>
-        <p:spPr>
-          <a:xfrm>
-            <a:off x="1284158" y="1726685"/>
-            <a:ext cx="3891197" cy="662742"/>
-          </a:xfrm>
-          <a:prstGeom prst="rect">
-            <a:avLst/>
-          </a:prstGeom>
-        </p:spPr>
-        <p:txBody>
-          <a:bodyPr vert="horz" lIns="91440" tIns="45720" rIns="91440" bIns="45720" rtlCol="0">
-            <a:normAutofit/>
-          </a:bodyPr>
-          <a:lstStyle>
-            <a:lvl1pPr marL="228600" indent="-228600" algn="l" defTabSz="914400" rtl="0" eaLnBrk="1" latinLnBrk="0" hangingPunct="1">
-              <a:lnSpc>
-                <a:spcPct val="90000"/>
-              </a:lnSpc>
-              <a:spcBef>
-                <a:spcPts val="1000"/>
-              </a:spcBef>
-              <a:buFont typeface="Arial" panose="020B0604020202020204" pitchFamily="34" charset="0"/>
-              <a:buChar char="•"/>
-              <a:defRPr sz="2800" kern="1200">
-                <a:solidFill>
-                  <a:schemeClr val="tx1"/>
-                </a:solidFill>
-                <a:latin typeface="+mn-lt"/>
-                <a:ea typeface="+mn-ea"/>
-                <a:cs typeface="+mn-cs"/>
-              </a:defRPr>
-            </a:lvl1pPr>
-            <a:lvl2pPr marL="685800" indent="-228600" algn="l" defTabSz="914400" rtl="0" eaLnBrk="1" latinLnBrk="0" hangingPunct="1">
-              <a:lnSpc>
-                <a:spcPct val="90000"/>
-              </a:lnSpc>
-              <a:spcBef>
-                <a:spcPts val="500"/>
-              </a:spcBef>
-              <a:buFont typeface="Arial" panose="020B0604020202020204" pitchFamily="34" charset="0"/>
-              <a:buChar char="•"/>
-              <a:defRPr sz="2400" kern="1200">
-                <a:solidFill>
-                  <a:schemeClr val="tx1"/>
-                </a:solidFill>
-                <a:latin typeface="+mn-lt"/>
-                <a:ea typeface="+mn-ea"/>
-                <a:cs typeface="+mn-cs"/>
-              </a:defRPr>
-            </a:lvl2pPr>
-            <a:lvl3pPr marL="1143000" indent="-228600" algn="l" defTabSz="914400" rtl="0" eaLnBrk="1" latinLnBrk="0" hangingPunct="1">
-              <a:lnSpc>
-                <a:spcPct val="90000"/>
-              </a:lnSpc>
-              <a:spcBef>
-                <a:spcPts val="500"/>
-              </a:spcBef>
-              <a:buFont typeface="Arial" panose="020B0604020202020204" pitchFamily="34" charset="0"/>
-              <a:buChar char="•"/>
-              <a:defRPr sz="2000" kern="1200">
-                <a:solidFill>
-                  <a:schemeClr val="tx1"/>
-                </a:solidFill>
-                <a:latin typeface="+mn-lt"/>
-                <a:ea typeface="+mn-ea"/>
-                <a:cs typeface="+mn-cs"/>
-              </a:defRPr>
-            </a:lvl3pPr>
-            <a:lvl4pPr marL="1600200" indent="-228600" algn="l" defTabSz="914400" rtl="0" eaLnBrk="1" latinLnBrk="0" hangingPunct="1">
-              <a:lnSpc>
-                <a:spcPct val="90000"/>
-              </a:lnSpc>
-              <a:spcBef>
-                <a:spcPts val="500"/>
-              </a:spcBef>
-              <a:buFont typeface="Arial" panose="020B0604020202020204" pitchFamily="34" charset="0"/>
-              <a:buChar char="•"/>
-              <a:defRPr sz="1800" kern="1200">
-                <a:solidFill>
-                  <a:schemeClr val="tx1"/>
-                </a:solidFill>
-                <a:latin typeface="+mn-lt"/>
-                <a:ea typeface="+mn-ea"/>
-                <a:cs typeface="+mn-cs"/>
-              </a:defRPr>
-            </a:lvl4pPr>
-            <a:lvl5pPr marL="2057400" indent="-228600" algn="l" defTabSz="914400" rtl="0" eaLnBrk="1" latinLnBrk="0" hangingPunct="1">
-              <a:lnSpc>
-                <a:spcPct val="90000"/>
-              </a:lnSpc>
-              <a:spcBef>
-                <a:spcPts val="500"/>
-              </a:spcBef>
-              <a:buFont typeface="Arial" panose="020B0604020202020204" pitchFamily="34" charset="0"/>
-              <a:buChar char="•"/>
-              <a:defRPr sz="1800" kern="1200">
-                <a:solidFill>
-                  <a:schemeClr val="tx1"/>
-                </a:solidFill>
-                <a:latin typeface="+mn-lt"/>
-                <a:ea typeface="+mn-ea"/>
-                <a:cs typeface="+mn-cs"/>
-              </a:defRPr>
-            </a:lvl5pPr>
-            <a:lvl6pPr marL="2514600" indent="-228600" algn="l" defTabSz="914400" rtl="0" eaLnBrk="1" latinLnBrk="0" hangingPunct="1">
-              <a:lnSpc>
-                <a:spcPct val="90000"/>
-              </a:lnSpc>
-              <a:spcBef>
-                <a:spcPts val="500"/>
-              </a:spcBef>
-              <a:buFont typeface="Arial" panose="020B0604020202020204" pitchFamily="34" charset="0"/>
-              <a:buChar char="•"/>
-              <a:defRPr sz="1800" kern="1200">
-                <a:solidFill>
-                  <a:schemeClr val="tx1"/>
-                </a:solidFill>
-                <a:latin typeface="+mn-lt"/>
-                <a:ea typeface="+mn-ea"/>
-                <a:cs typeface="+mn-cs"/>
-              </a:defRPr>
-            </a:lvl6pPr>
-            <a:lvl7pPr marL="2971800" indent="-228600" algn="l" defTabSz="914400" rtl="0" eaLnBrk="1" latinLnBrk="0" hangingPunct="1">
-              <a:lnSpc>
-                <a:spcPct val="90000"/>
-              </a:lnSpc>
-              <a:spcBef>
-                <a:spcPts val="500"/>
-              </a:spcBef>
-              <a:buFont typeface="Arial" panose="020B0604020202020204" pitchFamily="34" charset="0"/>
-              <a:buChar char="•"/>
-              <a:defRPr sz="1800" kern="1200">
-                <a:solidFill>
-                  <a:schemeClr val="tx1"/>
-                </a:solidFill>
-                <a:latin typeface="+mn-lt"/>
-                <a:ea typeface="+mn-ea"/>
-                <a:cs typeface="+mn-cs"/>
-              </a:defRPr>
-            </a:lvl7pPr>
-            <a:lvl8pPr marL="3429000" indent="-228600" algn="l" defTabSz="914400" rtl="0" eaLnBrk="1" latinLnBrk="0" hangingPunct="1">
-              <a:lnSpc>
-                <a:spcPct val="90000"/>
-              </a:lnSpc>
-              <a:spcBef>
-                <a:spcPts val="500"/>
-              </a:spcBef>
-              <a:buFont typeface="Arial" panose="020B0604020202020204" pitchFamily="34" charset="0"/>
-              <a:buChar char="•"/>
-              <a:defRPr sz="1800" kern="1200">
-                <a:solidFill>
-                  <a:schemeClr val="tx1"/>
-                </a:solidFill>
-                <a:latin typeface="+mn-lt"/>
-                <a:ea typeface="+mn-ea"/>
-                <a:cs typeface="+mn-cs"/>
-              </a:defRPr>
-            </a:lvl8pPr>
-            <a:lvl9pPr marL="3886200" indent="-228600" algn="l" defTabSz="914400" rtl="0" eaLnBrk="1" latinLnBrk="0" hangingPunct="1">
-              <a:lnSpc>
-                <a:spcPct val="90000"/>
-              </a:lnSpc>
-              <a:spcBef>
-                <a:spcPts val="500"/>
-              </a:spcBef>
-              <a:buFont typeface="Arial" panose="020B0604020202020204" pitchFamily="34" charset="0"/>
-              <a:buChar char="•"/>
-              <a:defRPr sz="1800" kern="1200">
-                <a:solidFill>
-                  <a:schemeClr val="tx1"/>
-                </a:solidFill>
-                <a:latin typeface="+mn-lt"/>
-                <a:ea typeface="+mn-ea"/>
-                <a:cs typeface="+mn-cs"/>
-              </a:defRPr>
-            </a:lvl9pPr>
-          </a:lstStyle>
-          <a:p>
-            <a:pPr marL="0" indent="0">
-              <a:buNone/>
-            </a:pPr>
-            <a:r>
-              <a:rPr lang="en-CA" sz="1800" dirty="0"/>
-              <a:t>Magnitude – post threshold probability</a:t>
-            </a:r>
-          </a:p>
-        </p:txBody>
-      </p:sp>
     </p:spTree>
     <p:extLst>
       <p:ext uri="{BB962C8B-B14F-4D97-AF65-F5344CB8AC3E}">
@@ -7612,7 +8025,7 @@
         <p:spPr>
           <a:xfrm>
             <a:off x="8650705" y="2079523"/>
-            <a:ext cx="3130216" cy="3967316"/>
+            <a:ext cx="3130216" cy="4303094"/>
           </a:xfrm>
         </p:spPr>
         <p:txBody>
@@ -7626,7 +8039,7 @@
             </a:pPr>
             <a:r>
               <a:rPr lang="en-US" sz="2600" dirty="0"/>
-              <a:t>The served rate gap difference from making Class 1 more delay-sensitive shows opposing trends over demand.</a:t>
+              <a:t>The served rate gap difference from making Class 1 more delay-sensitive shows opposing trends between balking and no-show over demand.</a:t>
             </a:r>
           </a:p>
           <a:p>
@@ -7649,10 +8062,10 @@
       </p:sp>
       <p:pic>
         <p:nvPicPr>
-          <p:cNvPr id="7" name="Content Placeholder 4">
+          <p:cNvPr id="5" name="Picture 4">
             <a:extLst>
               <a:ext uri="{FF2B5EF4-FFF2-40B4-BE49-F238E27FC236}">
-                <a16:creationId xmlns:a16="http://schemas.microsoft.com/office/drawing/2014/main" id="{773CE6E8-CBA3-482B-93E3-F2E9069B1BEC}"/>
+                <a16:creationId xmlns:a16="http://schemas.microsoft.com/office/drawing/2014/main" id="{E0142A85-F7AE-41CA-B119-7E94A6200579}"/>
               </a:ext>
             </a:extLst>
           </p:cNvPr>
@@ -7675,8 +8088,8 @@
         </p:blipFill>
         <p:spPr>
           <a:xfrm>
-            <a:off x="498439" y="1727128"/>
-            <a:ext cx="7839957" cy="4613514"/>
+            <a:off x="246748" y="1743745"/>
+            <a:ext cx="8275620" cy="4638872"/>
           </a:xfrm>
           <a:prstGeom prst="rect">
             <a:avLst/>

</xml_diff>